<commit_message>
Update PPT: live documentation/repo hyperlinks + built-feature claims
- Documentation and Code links now real hyperlinks (slides 2, 3, 6)
- Innovation/feasibility bullets reflect the shipped prototype: 3 metals,
  state-grid map, real 1,000-run Monte Carlo, k-NN imputer, CBAM, Hindi UI
- Demo video stays a placeholder until recorded

Co-Authored-By: Claude Fable 5 <noreply@anthropic.com>
</commit_message>
<xml_diff>
--- a/DhatuChakra_SIH_Idea.pptx
+++ b/DhatuChakra_SIH_Idea.pptx
@@ -6670,13 +6670,49 @@
               <a:t>Documentation:  </a:t>
             </a:r>
             <a:r>
-              <a:rPr sz="1050" b="0" i="1">
-                <a:solidFill>
-                  <a:srgbClr val="5A6B7B"/>
-                </a:solidFill>
-                <a:latin typeface="Segoe UI"/>
-              </a:rPr>
-              <a:t>&lt;add link&gt;</a:t>
+              <a:rPr sz="1050" b="0" i="0">
+                <a:solidFill>
+                  <a:srgbClr val="B84E0A"/>
+                </a:solidFill>
+                <a:latin typeface="Segoe UI"/>
+                <a:hlinkClick r:id="rId4"/>
+              </a:rPr>
+              <a:t>LCA-TOOL/docs · technical PDF</a:t>
+            </a:r>
+          </a:p>
+          <a:p>
+            <a:pPr>
+              <a:spcAft>
+                <a:spcPts val="100"/>
+              </a:spcAft>
+            </a:pPr>
+            <a:r>
+              <a:rPr sz="1050" b="1" i="0">
+                <a:solidFill>
+                  <a:srgbClr val="B84E0A"/>
+                </a:solidFill>
+                <a:latin typeface="Segoe UI"/>
+              </a:rPr>
+              <a:t>▸ </a:t>
+            </a:r>
+            <a:r>
+              <a:rPr sz="1050" b="1" i="0">
+                <a:solidFill>
+                  <a:srgbClr val="1C2B3A"/>
+                </a:solidFill>
+                <a:latin typeface="Segoe UI"/>
+              </a:rPr>
+              <a:t>Code + prototype:  </a:t>
+            </a:r>
+            <a:r>
+              <a:rPr sz="1050" b="0" i="0">
+                <a:solidFill>
+                  <a:srgbClr val="B84E0A"/>
+                </a:solidFill>
+                <a:latin typeface="Segoe UI"/>
+                <a:hlinkClick r:id="rId5"/>
+              </a:rPr>
+              <a:t>github.com/grv-io/LCA-TOOL</a:t>
             </a:r>
           </a:p>
         </p:txBody>
@@ -7027,7 +7063,7 @@
                 </a:solidFill>
                 <a:latin typeface="Segoe UI"/>
               </a:rPr>
-              <a:t>India-first data: </a:t>
+              <a:t>India-first: </a:t>
             </a:r>
             <a:r>
               <a:rPr sz="1150" b="0" i="0">
@@ -7036,7 +7072,7 @@
                 </a:solidFill>
                 <a:latin typeface="Segoe UI"/>
               </a:rPr>
-              <a:t>CEA grid intensity (0.71 kg CO₂/kWh), IBM Minerals Yearbook — global tools ignore Indian conditions</a:t>
+              <a:t>clickable state-grid map (CEA-derived: Himachal 0.18 → Chhattisgarh 0.92 kg CO₂/kWh) + CBAM export cost in ₹ crore</a:t>
             </a:r>
           </a:p>
           <a:p>
@@ -7070,7 +7106,7 @@
                 </a:solidFill>
                 <a:latin typeface="Segoe UI"/>
               </a:rPr>
-              <a:t>±9% ranges on every result; Monte Carlo (1,000 runs) in the full build</a:t>
+              <a:t>real 1,000-run Monte Carlo in the prototype — p05–p95 range + histogram on every result</a:t>
             </a:r>
           </a:p>
           <a:p>
@@ -7730,7 +7766,7 @@
                 </a:solidFill>
                 <a:latin typeface="Segoe UI"/>
               </a:rPr>
-              <a:t>same formulas, client-side HTML/JS — runs offline, zero backend.</a:t>
+              <a:t>client-side HTML/JS, offline — 3 metals, India state map, k-NN imputer (500 scenarios), 1,000-run Monte Carlo, CBAM, Hindi UI.</a:t>
             </a:r>
           </a:p>
         </p:txBody>
@@ -8468,7 +8504,7 @@
                 </a:solidFill>
                 <a:latin typeface="Segoe UI"/>
               </a:rPr>
-              <a:t>1,000 runs → ±9% uncertainty ranges</a:t>
+              <a:t>1,000 runs → p05–p95 ranges + histogram</a:t>
             </a:r>
           </a:p>
         </p:txBody>
@@ -8745,7 +8781,17 @@
                 </a:solidFill>
                 <a:latin typeface="Segoe UI"/>
               </a:rPr>
-              <a:t>demo video — &lt;add link&gt;   ·   documentation — &lt;add link&gt;</a:t>
+              <a:t>demo video — &lt;add link&gt;   ·   </a:t>
+            </a:r>
+            <a:r>
+              <a:rPr sz="1100" b="0" i="0">
+                <a:solidFill>
+                  <a:srgbClr val="B84E0A"/>
+                </a:solidFill>
+                <a:latin typeface="Segoe UI"/>
+                <a:hlinkClick r:id="rId4"/>
+              </a:rPr>
+              <a:t>technical documentation (PDF in repo)</a:t>
             </a:r>
           </a:p>
         </p:txBody>
@@ -9349,7 +9395,7 @@
                 </a:solidFill>
                 <a:latin typeface="Segoe UI"/>
               </a:rPr>
-              <a:t>Working prototype exists </a:t>
+              <a:t>Working prototype live </a:t>
             </a:r>
             <a:r>
               <a:rPr sz="1150" b="0" i="0">
@@ -9358,7 +9404,7 @@
                 </a:solidFill>
                 <a:latin typeface="Segoe UI"/>
               </a:rPr>
-              <a:t>— full calculation methodology runs client-side today; 4-week full-build plan is written</a:t>
+              <a:t>— 3 metals, state-grid map, k-NN imputer, Monte Carlo, CBAM calculator, Hindi UI; 4-week full-build plan written</a:t>
             </a:r>
           </a:p>
           <a:p>
@@ -11641,7 +11687,7 @@
               </a:spcAft>
             </a:pPr>
             <a:r>
-              <a:rPr sz="1150" b="1" i="0">
+              <a:rPr sz="1100" b="1" i="0">
                 <a:solidFill>
                   <a:srgbClr val="B84E0A"/>
                 </a:solidFill>
@@ -11650,7 +11696,7 @@
               <a:t>▸ </a:t>
             </a:r>
             <a:r>
-              <a:rPr sz="1150" b="1" i="0">
+              <a:rPr sz="1100" b="1" i="0">
                 <a:solidFill>
                   <a:srgbClr val="1C2B3A"/>
                 </a:solidFill>
@@ -11659,7 +11705,7 @@
               <a:t>Demo video:  </a:t>
             </a:r>
             <a:r>
-              <a:rPr sz="1150" b="0" i="1">
+              <a:rPr sz="1100" b="0" i="1">
                 <a:solidFill>
                   <a:srgbClr val="5A6B7B"/>
                 </a:solidFill>
@@ -11675,7 +11721,7 @@
               </a:spcAft>
             </a:pPr>
             <a:r>
-              <a:rPr sz="1150" b="1" i="0">
+              <a:rPr sz="1100" b="1" i="0">
                 <a:solidFill>
                   <a:srgbClr val="B84E0A"/>
                 </a:solidFill>
@@ -11684,22 +11730,23 @@
               <a:t>▸ </a:t>
             </a:r>
             <a:r>
-              <a:rPr sz="1150" b="1" i="0">
+              <a:rPr sz="1100" b="1" i="0">
                 <a:solidFill>
                   <a:srgbClr val="1C2B3A"/>
                 </a:solidFill>
                 <a:latin typeface="Segoe UI"/>
               </a:rPr>
-              <a:t>Documentation:  </a:t>
-            </a:r>
-            <a:r>
-              <a:rPr sz="1150" b="0" i="1">
-                <a:solidFill>
-                  <a:srgbClr val="5A6B7B"/>
-                </a:solidFill>
-                <a:latin typeface="Segoe UI"/>
-              </a:rPr>
-              <a:t>&lt;add link&gt;</a:t>
+              <a:t>Documentation (PDF):  </a:t>
+            </a:r>
+            <a:r>
+              <a:rPr sz="1100" b="0" i="0">
+                <a:solidFill>
+                  <a:srgbClr val="B84E0A"/>
+                </a:solidFill>
+                <a:latin typeface="Segoe UI"/>
+                <a:hlinkClick r:id="rId4"/>
+              </a:rPr>
+              <a:t>LCA-TOOL/docs/DhatuChakra_Documentation.pdf</a:t>
             </a:r>
           </a:p>
           <a:p>
@@ -11709,7 +11756,7 @@
               </a:spcAft>
             </a:pPr>
             <a:r>
-              <a:rPr sz="1150" b="1" i="0">
+              <a:rPr sz="1100" b="1" i="0">
                 <a:solidFill>
                   <a:srgbClr val="B84E0A"/>
                 </a:solidFill>
@@ -11718,22 +11765,23 @@
               <a:t>▸ </a:t>
             </a:r>
             <a:r>
-              <a:rPr sz="1150" b="1" i="0">
+              <a:rPr sz="1100" b="1" i="0">
                 <a:solidFill>
                   <a:srgbClr val="1C2B3A"/>
                 </a:solidFill>
                 <a:latin typeface="Segoe UI"/>
               </a:rPr>
-              <a:t>Live prototype:  </a:t>
-            </a:r>
-            <a:r>
-              <a:rPr sz="1150" b="0" i="1">
-                <a:solidFill>
-                  <a:srgbClr val="5A6B7B"/>
-                </a:solidFill>
-                <a:latin typeface="Segoe UI"/>
-              </a:rPr>
-              <a:t>&lt;add link&gt;</a:t>
+              <a:t>Code + prototype:  </a:t>
+            </a:r>
+            <a:r>
+              <a:rPr sz="1100" b="0" i="0">
+                <a:solidFill>
+                  <a:srgbClr val="B84E0A"/>
+                </a:solidFill>
+                <a:latin typeface="Segoe UI"/>
+                <a:hlinkClick r:id="rId5"/>
+              </a:rPr>
+              <a:t>github.com/grv-io/LCA-TOOL</a:t>
             </a:r>
           </a:p>
         </p:txBody>
@@ -11805,7 +11853,7 @@
                 </a:solidFill>
                 <a:latin typeface="Segoe UI"/>
               </a:rPr>
-              <a:t>Every number in this deck — 16.6, 0.92, 2.19, 0.70 t CO₂e/t, MCI 0.16→0.83, 62% electricity share — is computed from the sources listed and can be re-derived from our documentation.</a:t>
+              <a:t>Every number in this deck — 16.6, 0.92, 2.19, 0.70 t CO₂e/t, MCI 0.16→0.83, 62% electricity share — is computed from the sources listed; formulas and validation are in the linked technical PDF.</a:t>
             </a:r>
           </a:p>
         </p:txBody>

</xml_diff>

<commit_message>
PPT: reviewer-friendly rebuild — basics primer, implemented-vs-planned strip, validation table
- Slide 2: 'What is LCA / What is Circularity / Why metals, why now' primer row
  so non-domain reviewers get the fundamentals in 30 seconds
- Slide 3: IMPLEMENTED TODAY vs FULL BUILD status boxes under the flow diagram
- Slide 4: validation table (ours vs published ranges, 5 routes) replacing prose
- Scope row updated: copper is shipped, not a stretch goal

Co-Authored-By: Claude Fable 5 <noreply@anthropic.com>
</commit_message>
<xml_diff>
--- a/DhatuChakra_SIH_Idea.pptx
+++ b/DhatuChakra_SIH_Idea.pptx
@@ -6479,8 +6479,224 @@
         </p:nvSpPr>
         <p:spPr>
           <a:xfrm>
-            <a:off x="365760" y="1298448"/>
-            <a:ext cx="6903720" cy="932688"/>
+            <a:off x="365760" y="1280160"/>
+            <a:ext cx="3758184" cy="1133856"/>
+          </a:xfrm>
+          <a:prstGeom prst="roundRect">
+            <a:avLst>
+              <a:gd name="adj" fmla="val 6000"/>
+            </a:avLst>
+          </a:prstGeom>
+          <a:solidFill>
+            <a:srgbClr val="EBF1F7"/>
+          </a:solidFill>
+          <a:ln w="12700">
+            <a:solidFill>
+              <a:srgbClr val="24466E"/>
+            </a:solidFill>
+          </a:ln>
+          <a:effectLst/>
+        </p:spPr>
+        <p:style>
+          <a:lnRef idx="1">
+            <a:schemeClr val="accent1"/>
+          </a:lnRef>
+          <a:fillRef idx="3">
+            <a:schemeClr val="accent1"/>
+          </a:fillRef>
+          <a:effectRef idx="2">
+            <a:schemeClr val="accent1"/>
+          </a:effectRef>
+          <a:fontRef idx="minor">
+            <a:schemeClr val="lt1"/>
+          </a:fontRef>
+        </p:style>
+        <p:txBody>
+          <a:bodyPr rtlCol="0" anchor="t" wrap="square" lIns="109728" rIns="109728" tIns="64008" bIns="64008"/>
+          <a:lstStyle/>
+          <a:p>
+            <a:pPr algn="ctr">
+              <a:spcAft>
+                <a:spcPts val="200"/>
+              </a:spcAft>
+            </a:pPr>
+            <a:r>
+              <a:rPr sz="1100" b="1" i="0">
+                <a:solidFill>
+                  <a:srgbClr val="24466E"/>
+                </a:solidFill>
+                <a:latin typeface="Trebuchet MS"/>
+              </a:rPr>
+              <a:t>WHAT IS LCA?</a:t>
+            </a:r>
+          </a:p>
+          <a:p>
+            <a:r>
+              <a:rPr sz="930" b="0" i="0">
+                <a:solidFill>
+                  <a:srgbClr val="1C2B3A"/>
+                </a:solidFill>
+                <a:latin typeface="Segoe UI"/>
+              </a:rPr>
+              <a:t>Life Cycle Assessment totals a product's environmental cost across its life. Core method:  Impact = Σ (quantity × emission factor). We compute it cradle-to-gate, per tonne of metal.</a:t>
+            </a:r>
+          </a:p>
+        </p:txBody>
+      </p:sp>
+      <p:sp>
+        <p:nvSpPr>
+          <p:cNvPr id="15364" name="Rounded Rectangle 15363"/>
+          <p:cNvSpPr/>
+          <p:nvPr/>
+        </p:nvSpPr>
+        <p:spPr>
+          <a:xfrm>
+            <a:off x="4215384" y="1280160"/>
+            <a:ext cx="3758184" cy="1133856"/>
+          </a:xfrm>
+          <a:prstGeom prst="roundRect">
+            <a:avLst>
+              <a:gd name="adj" fmla="val 6000"/>
+            </a:avLst>
+          </a:prstGeom>
+          <a:solidFill>
+            <a:srgbClr val="E9F4EC"/>
+          </a:solidFill>
+          <a:ln w="12700">
+            <a:solidFill>
+              <a:srgbClr val="17803D"/>
+            </a:solidFill>
+          </a:ln>
+          <a:effectLst/>
+        </p:spPr>
+        <p:style>
+          <a:lnRef idx="1">
+            <a:schemeClr val="accent1"/>
+          </a:lnRef>
+          <a:fillRef idx="3">
+            <a:schemeClr val="accent1"/>
+          </a:fillRef>
+          <a:effectRef idx="2">
+            <a:schemeClr val="accent1"/>
+          </a:effectRef>
+          <a:fontRef idx="minor">
+            <a:schemeClr val="lt1"/>
+          </a:fontRef>
+        </p:style>
+        <p:txBody>
+          <a:bodyPr rtlCol="0" anchor="t" wrap="square" lIns="109728" rIns="109728" tIns="64008" bIns="64008"/>
+          <a:lstStyle/>
+          <a:p>
+            <a:pPr algn="ctr">
+              <a:spcAft>
+                <a:spcPts val="200"/>
+              </a:spcAft>
+            </a:pPr>
+            <a:r>
+              <a:rPr sz="1100" b="1" i="0">
+                <a:solidFill>
+                  <a:srgbClr val="17803D"/>
+                </a:solidFill>
+                <a:latin typeface="Trebuchet MS"/>
+              </a:rPr>
+              <a:t>WHAT IS CIRCULARITY?</a:t>
+            </a:r>
+          </a:p>
+          <a:p>
+            <a:r>
+              <a:rPr sz="930" b="0" i="0">
+                <a:solidFill>
+                  <a:srgbClr val="1C2B3A"/>
+                </a:solidFill>
+                <a:latin typeface="Segoe UI"/>
+              </a:rPr>
+              <a:t>How much material loops back (scrap, recycling) instead of being mined and landfilled. Scored 0→1 by the Material Circularity Indicator (Ellen MacArthur): 0 = fully linear, 1 = fully circular.</a:t>
+            </a:r>
+          </a:p>
+        </p:txBody>
+      </p:sp>
+      <p:sp>
+        <p:nvSpPr>
+          <p:cNvPr id="15365" name="Rounded Rectangle 15364"/>
+          <p:cNvSpPr/>
+          <p:nvPr/>
+        </p:nvSpPr>
+        <p:spPr>
+          <a:xfrm>
+            <a:off x="8065008" y="1280160"/>
+            <a:ext cx="3758184" cy="1133856"/>
+          </a:xfrm>
+          <a:prstGeom prst="roundRect">
+            <a:avLst>
+              <a:gd name="adj" fmla="val 6000"/>
+            </a:avLst>
+          </a:prstGeom>
+          <a:solidFill>
+            <a:srgbClr val="FCEFE3"/>
+          </a:solidFill>
+          <a:ln w="12700">
+            <a:solidFill>
+              <a:srgbClr val="B84E0A"/>
+            </a:solidFill>
+          </a:ln>
+          <a:effectLst/>
+        </p:spPr>
+        <p:style>
+          <a:lnRef idx="1">
+            <a:schemeClr val="accent1"/>
+          </a:lnRef>
+          <a:fillRef idx="3">
+            <a:schemeClr val="accent1"/>
+          </a:fillRef>
+          <a:effectRef idx="2">
+            <a:schemeClr val="accent1"/>
+          </a:effectRef>
+          <a:fontRef idx="minor">
+            <a:schemeClr val="lt1"/>
+          </a:fontRef>
+        </p:style>
+        <p:txBody>
+          <a:bodyPr rtlCol="0" anchor="t" wrap="square" lIns="109728" rIns="109728" tIns="64008" bIns="64008"/>
+          <a:lstStyle/>
+          <a:p>
+            <a:pPr algn="ctr">
+              <a:spcAft>
+                <a:spcPts val="200"/>
+              </a:spcAft>
+            </a:pPr>
+            <a:r>
+              <a:rPr sz="1100" b="1" i="0">
+                <a:solidFill>
+                  <a:srgbClr val="B84E0A"/>
+                </a:solidFill>
+                <a:latin typeface="Trebuchet MS"/>
+              </a:rPr>
+              <a:t>WHY METALS, WHY NOW?</a:t>
+            </a:r>
+          </a:p>
+          <a:p>
+            <a:r>
+              <a:rPr sz="930" b="0" i="0">
+                <a:solidFill>
+                  <a:srgbClr val="1C2B3A"/>
+                </a:solidFill>
+                <a:latin typeface="Segoe UI"/>
+              </a:rPr>
+              <a:t>Metals ≈ 8% of global CO₂. India: circular-economy policy + National Critical Mineral Mission. EU CBAM taxes embedded carbon in steel/aluminium exports from 2026.</a:t>
+            </a:r>
+          </a:p>
+        </p:txBody>
+      </p:sp>
+      <p:sp>
+        <p:nvSpPr>
+          <p:cNvPr id="15366" name="Rounded Rectangle 15365"/>
+          <p:cNvSpPr/>
+          <p:nvPr/>
+        </p:nvSpPr>
+        <p:spPr>
+          <a:xfrm>
+            <a:off x="365760" y="2523744"/>
+            <a:ext cx="6903720" cy="786384"/>
           </a:xfrm>
           <a:prstGeom prst="roundRect">
             <a:avLst>
@@ -6515,13 +6731,9 @@
           <a:bodyPr rtlCol="0" anchor="t" wrap="square" lIns="109728" rIns="109728" tIns="64008" bIns="64008"/>
           <a:lstStyle/>
           <a:p>
-            <a:pPr algn="ctr">
-              <a:spcAft>
-                <a:spcPts val="100"/>
-              </a:spcAft>
-            </a:pPr>
-            <a:r>
-              <a:rPr sz="2200" b="1" i="0">
+            <a:pPr algn="ctr"/>
+            <a:r>
+              <a:rPr sz="1700" b="1" i="0">
                 <a:solidFill>
                   <a:srgbClr val="B84E0A"/>
                 </a:solidFill>
@@ -6530,38 +6742,36 @@
               <a:t>DhatuChakra </a:t>
             </a:r>
             <a:r>
-              <a:rPr sz="1600" b="0" i="0">
+              <a:rPr sz="1300" b="0" i="0">
                 <a:solidFill>
                   <a:srgbClr val="1C2B3A"/>
                 </a:solidFill>
                 <a:latin typeface="Nirmala UI"/>
               </a:rPr>
-              <a:t>(धातुचक्र)</a:t>
-            </a:r>
-          </a:p>
-          <a:p>
-            <a:r>
-              <a:rPr sz="1150" b="0" i="0">
+              <a:t>(धातुचक्र)  </a:t>
+            </a:r>
+            <a:r>
+              <a:rPr sz="1050" b="0" i="0">
                 <a:solidFill>
                   <a:srgbClr val="1C2B3A"/>
                 </a:solidFill>
                 <a:latin typeface="Segoe UI"/>
               </a:rPr>
-              <a:t>AI-assisted life-cycle assessment &amp; circularity engine for Indian metals — 5 inputs in, ISO-14044-style answers out.</a:t>
-            </a:r>
-          </a:p>
-        </p:txBody>
-      </p:sp>
-      <p:sp>
-        <p:nvSpPr>
-          <p:cNvPr id="15364" name="Rounded Rectangle 15363"/>
+              <a:t>— AI-assisted LCA &amp; circularity engine for Indian metals: 5 inputs in, ISO-14044-style answers out.</a:t>
+            </a:r>
+          </a:p>
+        </p:txBody>
+      </p:sp>
+      <p:sp>
+        <p:nvSpPr>
+          <p:cNvPr id="15367" name="Rounded Rectangle 15366"/>
           <p:cNvSpPr/>
           <p:nvPr/>
         </p:nvSpPr>
         <p:spPr>
           <a:xfrm>
-            <a:off x="7452360" y="1298448"/>
-            <a:ext cx="4370832" cy="932688"/>
+            <a:off x="7452360" y="2523744"/>
+            <a:ext cx="4370832" cy="786384"/>
           </a:xfrm>
           <a:prstGeom prst="roundRect">
             <a:avLst>
@@ -6593,22 +6803,40 @@
           </a:fontRef>
         </p:style>
         <p:txBody>
-          <a:bodyPr rtlCol="0" anchor="t" wrap="square" lIns="109728" rIns="109728" tIns="64008" bIns="64008"/>
+          <a:bodyPr rtlCol="0" anchor="t" wrap="square" lIns="109728" rIns="109728" tIns="36576" bIns="64008"/>
           <a:lstStyle/>
           <a:p>
             <a:pPr algn="ctr">
               <a:spcAft>
-                <a:spcPts val="200"/>
+                <a:spcPts val="100"/>
               </a:spcAft>
             </a:pPr>
             <a:r>
-              <a:rPr sz="1100" b="1" i="0">
-                <a:solidFill>
-                  <a:srgbClr val="24466E"/>
-                </a:solidFill>
-                <a:latin typeface="Segoe UI"/>
-              </a:rPr>
-              <a:t>Working prototype — see it run</a:t>
+              <a:rPr sz="950" b="1" i="0">
+                <a:solidFill>
+                  <a:srgbClr val="B84E0A"/>
+                </a:solidFill>
+                <a:latin typeface="Segoe UI"/>
+              </a:rPr>
+              <a:t>▸ </a:t>
+            </a:r>
+            <a:r>
+              <a:rPr sz="950" b="1" i="0">
+                <a:solidFill>
+                  <a:srgbClr val="1C2B3A"/>
+                </a:solidFill>
+                <a:latin typeface="Segoe UI"/>
+              </a:rPr>
+              <a:t>Demo video:  </a:t>
+            </a:r>
+            <a:r>
+              <a:rPr sz="950" b="0" i="1">
+                <a:solidFill>
+                  <a:srgbClr val="5A6B7B"/>
+                </a:solidFill>
+                <a:latin typeface="Segoe UI"/>
+              </a:rPr>
+              <a:t>&lt;add link&gt;</a:t>
             </a:r>
           </a:p>
           <a:p>
@@ -6618,7 +6846,7 @@
               </a:spcAft>
             </a:pPr>
             <a:r>
-              <a:rPr sz="1050" b="1" i="0">
+              <a:rPr sz="950" b="1" i="0">
                 <a:solidFill>
                   <a:srgbClr val="B84E0A"/>
                 </a:solidFill>
@@ -6627,22 +6855,23 @@
               <a:t>▸ </a:t>
             </a:r>
             <a:r>
-              <a:rPr sz="1050" b="1" i="0">
+              <a:rPr sz="950" b="1" i="0">
                 <a:solidFill>
                   <a:srgbClr val="1C2B3A"/>
                 </a:solidFill>
                 <a:latin typeface="Segoe UI"/>
               </a:rPr>
-              <a:t>Demo video:  </a:t>
-            </a:r>
-            <a:r>
-              <a:rPr sz="1050" b="0" i="1">
-                <a:solidFill>
-                  <a:srgbClr val="5A6B7B"/>
-                </a:solidFill>
-                <a:latin typeface="Segoe UI"/>
-              </a:rPr>
-              <a:t>&lt;add link&gt;</a:t>
+              <a:t>Documentation:  </a:t>
+            </a:r>
+            <a:r>
+              <a:rPr sz="950" b="0" i="0">
+                <a:solidFill>
+                  <a:srgbClr val="B84E0A"/>
+                </a:solidFill>
+                <a:latin typeface="Segoe UI"/>
+                <a:hlinkClick r:id="rId4"/>
+              </a:rPr>
+              <a:t>LCA-TOOL/docs · technical PDF</a:t>
             </a:r>
           </a:p>
           <a:p>
@@ -6652,7 +6881,7 @@
               </a:spcAft>
             </a:pPr>
             <a:r>
-              <a:rPr sz="1050" b="1" i="0">
+              <a:rPr sz="950" b="1" i="0">
                 <a:solidFill>
                   <a:srgbClr val="B84E0A"/>
                 </a:solidFill>
@@ -6661,55 +6890,20 @@
               <a:t>▸ </a:t>
             </a:r>
             <a:r>
-              <a:rPr sz="1050" b="1" i="0">
+              <a:rPr sz="950" b="1" i="0">
                 <a:solidFill>
                   <a:srgbClr val="1C2B3A"/>
                 </a:solidFill>
                 <a:latin typeface="Segoe UI"/>
               </a:rPr>
-              <a:t>Documentation:  </a:t>
-            </a:r>
-            <a:r>
-              <a:rPr sz="1050" b="0" i="0">
+              <a:t>Code + prototype:  </a:t>
+            </a:r>
+            <a:r>
+              <a:rPr sz="950" b="0" i="0">
                 <a:solidFill>
                   <a:srgbClr val="B84E0A"/>
                 </a:solidFill>
                 <a:latin typeface="Segoe UI"/>
-                <a:hlinkClick r:id="rId4"/>
-              </a:rPr>
-              <a:t>LCA-TOOL/docs · technical PDF</a:t>
-            </a:r>
-          </a:p>
-          <a:p>
-            <a:pPr>
-              <a:spcAft>
-                <a:spcPts val="100"/>
-              </a:spcAft>
-            </a:pPr>
-            <a:r>
-              <a:rPr sz="1050" b="1" i="0">
-                <a:solidFill>
-                  <a:srgbClr val="B84E0A"/>
-                </a:solidFill>
-                <a:latin typeface="Segoe UI"/>
-              </a:rPr>
-              <a:t>▸ </a:t>
-            </a:r>
-            <a:r>
-              <a:rPr sz="1050" b="1" i="0">
-                <a:solidFill>
-                  <a:srgbClr val="1C2B3A"/>
-                </a:solidFill>
-                <a:latin typeface="Segoe UI"/>
-              </a:rPr>
-              <a:t>Code + prototype:  </a:t>
-            </a:r>
-            <a:r>
-              <a:rPr sz="1050" b="0" i="0">
-                <a:solidFill>
-                  <a:srgbClr val="B84E0A"/>
-                </a:solidFill>
-                <a:latin typeface="Segoe UI"/>
                 <a:hlinkClick r:id="rId5"/>
               </a:rPr>
               <a:t>github.com/grv-io/LCA-TOOL</a:t>
@@ -6719,14 +6913,14 @@
       </p:sp>
       <p:sp>
         <p:nvSpPr>
-          <p:cNvPr id="15365" name="Rounded Rectangle 15364"/>
+          <p:cNvPr id="15368" name="Rounded Rectangle 15367"/>
           <p:cNvSpPr/>
           <p:nvPr/>
         </p:nvSpPr>
         <p:spPr>
           <a:xfrm>
-            <a:off x="365760" y="2395728"/>
-            <a:ext cx="5577840" cy="3767328"/>
+            <a:off x="365760" y="3438144"/>
+            <a:ext cx="5577840" cy="2761488"/>
           </a:xfrm>
           <a:prstGeom prst="roundRect">
             <a:avLst>
@@ -6763,11 +6957,11 @@
           <a:p>
             <a:pPr algn="ctr">
               <a:spcAft>
-                <a:spcPts val="600"/>
+                <a:spcPts val="400"/>
               </a:spcAft>
             </a:pPr>
             <a:r>
-              <a:rPr sz="1500" b="1" i="0">
+              <a:rPr sz="1300" b="1" i="0">
                 <a:solidFill>
                   <a:srgbClr val="24466E"/>
                 </a:solidFill>
@@ -6779,11 +6973,11 @@
           <a:p>
             <a:pPr>
               <a:spcAft>
-                <a:spcPts val="700"/>
+                <a:spcPts val="500"/>
               </a:spcAft>
             </a:pPr>
             <a:r>
-              <a:rPr sz="1150" b="1" i="0">
+              <a:rPr sz="1050" b="1" i="0">
                 <a:solidFill>
                   <a:srgbClr val="B84E0A"/>
                 </a:solidFill>
@@ -6792,32 +6986,32 @@
               <a:t>•  </a:t>
             </a:r>
             <a:r>
-              <a:rPr sz="1150" b="1" i="0">
+              <a:rPr sz="1050" b="1" i="0">
                 <a:solidFill>
                   <a:srgbClr val="1C2B3A"/>
                 </a:solidFill>
                 <a:latin typeface="Segoe UI"/>
               </a:rPr>
-              <a:t>LCA today is out of reach: </a:t>
-            </a:r>
-            <a:r>
-              <a:rPr sz="1150" b="0" i="0">
+              <a:t>Conventional LCA is out of reach: </a:t>
+            </a:r>
+            <a:r>
+              <a:rPr sz="1050" b="0" i="0">
                 <a:solidFill>
                   <a:srgbClr val="1C2B3A"/>
                 </a:solidFill>
                 <a:latin typeface="Segoe UI"/>
               </a:rPr>
-              <a:t>25+ process parameters, database licences (ecoinvent ≈ €4,000/yr), weeks of consultants — most Indian plants simply skip it</a:t>
+              <a:t>25+ parameters, database licences ≈ €4,000/yr, weeks of consultants — most Indian plants skip it</a:t>
             </a:r>
           </a:p>
           <a:p>
             <a:pPr>
               <a:spcAft>
-                <a:spcPts val="700"/>
+                <a:spcPts val="500"/>
               </a:spcAft>
             </a:pPr>
             <a:r>
-              <a:rPr sz="1150" b="1" i="0">
+              <a:rPr sz="1050" b="1" i="0">
                 <a:solidFill>
                   <a:srgbClr val="B84E0A"/>
                 </a:solidFill>
@@ -6826,7 +7020,7 @@
               <a:t>•  </a:t>
             </a:r>
             <a:r>
-              <a:rPr sz="1150" b="1" i="0">
+              <a:rPr sz="1050" b="1" i="0">
                 <a:solidFill>
                   <a:srgbClr val="1C2B3A"/>
                 </a:solidFill>
@@ -6835,23 +7029,23 @@
               <a:t>DhatuChakra needs 5–8 inputs </a:t>
             </a:r>
             <a:r>
-              <a:rPr sz="1150" b="0" i="0">
+              <a:rPr sz="1050" b="0" i="0">
                 <a:solidFill>
                   <a:srgbClr val="1C2B3A"/>
                 </a:solidFill>
                 <a:latin typeface="Segoe UI"/>
               </a:rPr>
-              <a:t>— or one plain sentence ("aluminium smelter in Odisha, 40% scrap"); an LLM parses it into a structured scenario</a:t>
+              <a:t>or one plain sentence ("aluminium smelter in Odisha, 40% scrap") → full profile in seconds</a:t>
             </a:r>
           </a:p>
           <a:p>
             <a:pPr>
               <a:spcAft>
-                <a:spcPts val="700"/>
+                <a:spcPts val="500"/>
               </a:spcAft>
             </a:pPr>
             <a:r>
-              <a:rPr sz="1150" b="1" i="0">
+              <a:rPr sz="1050" b="1" i="0">
                 <a:solidFill>
                   <a:srgbClr val="B84E0A"/>
                 </a:solidFill>
@@ -6860,32 +7054,32 @@
               <a:t>•  </a:t>
             </a:r>
             <a:r>
-              <a:rPr sz="1150" b="1" i="0">
+              <a:rPr sz="1050" b="1" i="0">
                 <a:solidFill>
                   <a:srgbClr val="1C2B3A"/>
                 </a:solidFill>
                 <a:latin typeface="Segoe UI"/>
               </a:rPr>
-              <a:t>AI fills every missing parameter </a:t>
-            </a:r>
-            <a:r>
-              <a:rPr sz="1150" b="0" i="0">
+              <a:t>AI fills the missing parameters </a:t>
+            </a:r>
+            <a:r>
+              <a:rPr sz="1050" b="0" i="0">
                 <a:solidFill>
                   <a:srgbClr val="1C2B3A"/>
                 </a:solidFill>
                 <a:latin typeface="Segoe UI"/>
               </a:rPr>
-              <a:t>with a confidence score — estimates are visibly flagged, never hidden</a:t>
+              <a:t>with visible confidence scores — estimates flagged, never hidden, always overridable</a:t>
             </a:r>
           </a:p>
           <a:p>
             <a:pPr>
               <a:spcAft>
-                <a:spcPts val="700"/>
+                <a:spcPts val="500"/>
               </a:spcAft>
             </a:pPr>
             <a:r>
-              <a:rPr sz="1150" b="1" i="0">
+              <a:rPr sz="1050" b="1" i="0">
                 <a:solidFill>
                   <a:srgbClr val="B84E0A"/>
                 </a:solidFill>
@@ -6894,70 +7088,36 @@
               <a:t>•  </a:t>
             </a:r>
             <a:r>
-              <a:rPr sz="1150" b="1" i="0">
+              <a:rPr sz="1050" b="1" i="0">
                 <a:solidFill>
                   <a:srgbClr val="1C2B3A"/>
                 </a:solidFill>
                 <a:latin typeface="Segoe UI"/>
               </a:rPr>
-              <a:t>Full picture per tonne: </a:t>
-            </a:r>
-            <a:r>
-              <a:rPr sz="1150" b="0" i="0">
+              <a:t>Output per tonne: </a:t>
+            </a:r>
+            <a:r>
+              <a:rPr sz="1050" b="0" i="0">
                 <a:solidFill>
                   <a:srgbClr val="1C2B3A"/>
                 </a:solidFill>
                 <a:latin typeface="Segoe UI"/>
               </a:rPr>
-              <a:t>GWP, energy, water, acidification + Material Circularity Indicator (Ellen MacArthur v3)</a:t>
-            </a:r>
-          </a:p>
-          <a:p>
-            <a:pPr>
-              <a:spcAft>
-                <a:spcPts val="700"/>
-              </a:spcAft>
-            </a:pPr>
-            <a:r>
-              <a:rPr sz="1150" b="1" i="0">
-                <a:solidFill>
-                  <a:srgbClr val="B84E0A"/>
-                </a:solidFill>
-                <a:latin typeface="Segoe UI"/>
-              </a:rPr>
-              <a:t>•  </a:t>
-            </a:r>
-            <a:r>
-              <a:rPr sz="1150" b="1" i="0">
-                <a:solidFill>
-                  <a:srgbClr val="1C2B3A"/>
-                </a:solidFill>
-                <a:latin typeface="Segoe UI"/>
-              </a:rPr>
-              <a:t>Decision tool, not a calculator: </a:t>
-            </a:r>
-            <a:r>
-              <a:rPr sz="1150" b="0" i="0">
-                <a:solidFill>
-                  <a:srgbClr val="1C2B3A"/>
-                </a:solidFill>
-                <a:latin typeface="Segoe UI"/>
-              </a:rPr>
-              <a:t>linear-vs-circular compare with live sliders + auditable PDF report</a:t>
-            </a:r>
-          </a:p>
-        </p:txBody>
-      </p:sp>
-      <p:sp>
-        <p:nvSpPr>
-          <p:cNvPr id="15366" name="Rounded Rectangle 15365"/>
+              <a:t>GWP · energy · water · acidification + MCI, live linear-vs-circular compare, auditable PDF report</a:t>
+            </a:r>
+          </a:p>
+        </p:txBody>
+      </p:sp>
+      <p:sp>
+        <p:nvSpPr>
+          <p:cNvPr id="15369" name="Rounded Rectangle 15368"/>
           <p:cNvSpPr/>
           <p:nvPr/>
         </p:nvSpPr>
         <p:spPr>
           <a:xfrm>
-            <a:off x="6217920" y="2395728"/>
-            <a:ext cx="5605272" cy="3767328"/>
+            <a:off x="6217920" y="3438144"/>
+            <a:ext cx="5605272" cy="2761488"/>
           </a:xfrm>
           <a:prstGeom prst="roundRect">
             <a:avLst>
@@ -6994,11 +7154,11 @@
           <a:p>
             <a:pPr algn="ctr">
               <a:spcAft>
-                <a:spcPts val="600"/>
+                <a:spcPts val="400"/>
               </a:spcAft>
             </a:pPr>
             <a:r>
-              <a:rPr sz="1500" b="1" i="0">
+              <a:rPr sz="1300" b="1" i="0">
                 <a:solidFill>
                   <a:srgbClr val="24466E"/>
                 </a:solidFill>
@@ -7010,11 +7170,11 @@
           <a:p>
             <a:pPr>
               <a:spcAft>
-                <a:spcPts val="600"/>
+                <a:spcPts val="500"/>
               </a:spcAft>
             </a:pPr>
             <a:r>
-              <a:rPr sz="1150" b="1" i="0">
+              <a:rPr sz="1050" b="1" i="0">
                 <a:solidFill>
                   <a:srgbClr val="B84E0A"/>
                 </a:solidFill>
@@ -7023,7 +7183,7 @@
               <a:t>•  </a:t>
             </a:r>
             <a:r>
-              <a:rPr sz="1150" b="1" i="0">
+              <a:rPr sz="1050" b="1" i="0">
                 <a:solidFill>
                   <a:srgbClr val="1C2B3A"/>
                 </a:solidFill>
@@ -7032,23 +7192,23 @@
               <a:t>Not a black box: </a:t>
             </a:r>
             <a:r>
-              <a:rPr sz="1150" b="0" i="0">
+              <a:rPr sz="1050" b="0" i="0">
                 <a:solidFill>
                   <a:srgbClr val="1C2B3A"/>
                 </a:solidFill>
                 <a:latin typeface="Segoe UI"/>
               </a:rPr>
-              <a:t>every figure traces to a cited public factor — source, year, region shown in-app</a:t>
+              <a:t>every figure traces to a cited public source (CEA, IAI, worldsteel, EF 3.1) — shown in-app</a:t>
             </a:r>
           </a:p>
           <a:p>
             <a:pPr>
               <a:spcAft>
-                <a:spcPts val="600"/>
+                <a:spcPts val="500"/>
               </a:spcAft>
             </a:pPr>
             <a:r>
-              <a:rPr sz="1150" b="1" i="0">
+              <a:rPr sz="1050" b="1" i="0">
                 <a:solidFill>
                   <a:srgbClr val="B84E0A"/>
                 </a:solidFill>
@@ -7057,7 +7217,7 @@
               <a:t>•  </a:t>
             </a:r>
             <a:r>
-              <a:rPr sz="1150" b="1" i="0">
+              <a:rPr sz="1050" b="1" i="0">
                 <a:solidFill>
                   <a:srgbClr val="1C2B3A"/>
                 </a:solidFill>
@@ -7066,23 +7226,23 @@
               <a:t>India-first: </a:t>
             </a:r>
             <a:r>
-              <a:rPr sz="1150" b="0" i="0">
+              <a:rPr sz="1050" b="0" i="0">
                 <a:solidFill>
                   <a:srgbClr val="1C2B3A"/>
                 </a:solidFill>
                 <a:latin typeface="Segoe UI"/>
               </a:rPr>
-              <a:t>clickable state-grid map (CEA-derived: Himachal 0.18 → Chhattisgarh 0.92 kg CO₂/kWh) + CBAM export cost in ₹ crore</a:t>
+              <a:t>clickable state-grid map (Himachal 0.18 → Chhattisgarh 0.92 kg CO₂/kWh) + CBAM export cost in ₹ crore</a:t>
             </a:r>
           </a:p>
           <a:p>
             <a:pPr>
               <a:spcAft>
-                <a:spcPts val="600"/>
+                <a:spcPts val="500"/>
               </a:spcAft>
             </a:pPr>
             <a:r>
-              <a:rPr sz="1150" b="1" i="0">
+              <a:rPr sz="1050" b="1" i="0">
                 <a:solidFill>
                   <a:srgbClr val="B84E0A"/>
                 </a:solidFill>
@@ -7091,32 +7251,32 @@
               <a:t>•  </a:t>
             </a:r>
             <a:r>
-              <a:rPr sz="1150" b="1" i="0">
+              <a:rPr sz="1050" b="1" i="0">
                 <a:solidFill>
                   <a:srgbClr val="1C2B3A"/>
                 </a:solidFill>
                 <a:latin typeface="Segoe UI"/>
               </a:rPr>
-              <a:t>Uncertainty built in: </a:t>
-            </a:r>
-            <a:r>
-              <a:rPr sz="1150" b="0" i="0">
+              <a:t>Real statistics, real ML: </a:t>
+            </a:r>
+            <a:r>
+              <a:rPr sz="1050" b="0" i="0">
                 <a:solidFill>
                   <a:srgbClr val="1C2B3A"/>
                 </a:solidFill>
                 <a:latin typeface="Segoe UI"/>
               </a:rPr>
-              <a:t>real 1,000-run Monte Carlo in the prototype — p05–p95 range + histogram on every result</a:t>
+              <a:t>1,000-run Monte Carlo (p05–p95 on every result) + k-NN imputer with honest confidence</a:t>
             </a:r>
           </a:p>
           <a:p>
             <a:pPr>
               <a:spcAft>
-                <a:spcPts val="600"/>
+                <a:spcPts val="500"/>
               </a:spcAft>
             </a:pPr>
             <a:r>
-              <a:rPr sz="1150" b="1" i="0">
+              <a:rPr sz="1050" b="1" i="0">
                 <a:solidFill>
                   <a:srgbClr val="B84E0A"/>
                 </a:solidFill>
@@ -7125,67 +7285,33 @@
               <a:t>•  </a:t>
             </a:r>
             <a:r>
-              <a:rPr sz="1150" b="1" i="0">
+              <a:rPr sz="1050" b="1" i="0">
                 <a:solidFill>
                   <a:srgbClr val="1C2B3A"/>
                 </a:solidFill>
                 <a:latin typeface="Segoe UI"/>
               </a:rPr>
-              <a:t>Instant what-if: </a:t>
-            </a:r>
-            <a:r>
-              <a:rPr sz="1150" b="0" i="0">
+              <a:t>₹0 data cost: </a:t>
+            </a:r>
+            <a:r>
+              <a:rPr sz="1050" b="0" i="0">
                 <a:solidFill>
                   <a:srgbClr val="1C2B3A"/>
                 </a:solidFill>
                 <a:latin typeface="Segoe UI"/>
               </a:rPr>
-              <a:t>surrogate model answers sliders in milliseconds — prototype already proves the UX</a:t>
-            </a:r>
-          </a:p>
-          <a:p>
-            <a:pPr>
-              <a:spcAft>
-                <a:spcPts val="600"/>
-              </a:spcAft>
-            </a:pPr>
-            <a:r>
-              <a:rPr sz="1150" b="1" i="0">
-                <a:solidFill>
-                  <a:srgbClr val="B84E0A"/>
-                </a:solidFill>
-                <a:latin typeface="Segoe UI"/>
-              </a:rPr>
-              <a:t>•  </a:t>
-            </a:r>
-            <a:r>
-              <a:rPr sz="1150" b="1" i="0">
-                <a:solidFill>
-                  <a:srgbClr val="1C2B3A"/>
-                </a:solidFill>
-                <a:latin typeface="Segoe UI"/>
-              </a:rPr>
-              <a:t>₹0 data cost: </a:t>
-            </a:r>
-            <a:r>
-              <a:rPr sz="1150" b="0" i="0">
-                <a:solidFill>
-                  <a:srgbClr val="1C2B3A"/>
-                </a:solidFill>
-                <a:latin typeface="Segoe UI"/>
-              </a:rPr>
-              <a:t>built entirely on free public inventories (IAI, worldsteel, EF 3.1, IDEMAT, US LCI)</a:t>
-            </a:r>
-          </a:p>
-          <a:p>
-            <a:r>
-              <a:rPr sz="1100" b="1" i="0">
+              <a:t>built entirely on free public inventories — no ecoinvent licence anywhere</a:t>
+            </a:r>
+          </a:p>
+          <a:p>
+            <a:r>
+              <a:rPr sz="1050" b="1" i="0">
                 <a:solidFill>
                   <a:srgbClr val="17803D"/>
                 </a:solidFill>
                 <a:latin typeface="Segoe UI"/>
               </a:rPr>
-              <a:t>Verified: recycled aluminium route = 16.6 → 0.92 t CO₂e/t (−94%), inside IAI published ranges.</a:t>
+              <a:t>Verified: recycled aluminium = 16.6 → 0.92 t CO₂e/t (−94%), inside IAI published ranges.</a:t>
             </a:r>
           </a:p>
         </p:txBody>
@@ -8745,53 +8871,163 @@
       </p:sp>
       <p:sp>
         <p:nvSpPr>
-          <p:cNvPr id="17429" name="TextBox 17428"/>
-          <p:cNvSpPr txBox="1"/>
+          <p:cNvPr id="17429" name="Rounded Rectangle 17428"/>
+          <p:cNvSpPr/>
           <p:nvPr/>
         </p:nvSpPr>
         <p:spPr>
           <a:xfrm>
-            <a:off x="3886200" y="5349240"/>
-            <a:ext cx="7909560" cy="822960"/>
+            <a:off x="3886200" y="5248656"/>
+            <a:ext cx="3886200" cy="950976"/>
           </a:xfrm>
-          <a:prstGeom prst="rect">
-            <a:avLst/>
+          <a:prstGeom prst="roundRect">
+            <a:avLst>
+              <a:gd name="adj" fmla="val 6000"/>
+            </a:avLst>
           </a:prstGeom>
-          <a:noFill/>
+          <a:solidFill>
+            <a:srgbClr val="E9F4EC"/>
+          </a:solidFill>
+          <a:ln w="12700">
+            <a:solidFill>
+              <a:srgbClr val="17803D"/>
+            </a:solidFill>
+          </a:ln>
+          <a:effectLst/>
         </p:spPr>
-        <p:txBody>
-          <a:bodyPr wrap="square">
-            <a:spAutoFit/>
-          </a:bodyPr>
+        <p:style>
+          <a:lnRef idx="1">
+            <a:schemeClr val="accent1"/>
+          </a:lnRef>
+          <a:fillRef idx="3">
+            <a:schemeClr val="accent1"/>
+          </a:fillRef>
+          <a:effectRef idx="2">
+            <a:schemeClr val="accent1"/>
+          </a:effectRef>
+          <a:fontRef idx="minor">
+            <a:schemeClr val="lt1"/>
+          </a:fontRef>
+        </p:style>
+        <p:txBody>
+          <a:bodyPr rtlCol="0" anchor="t" wrap="square" lIns="109728" rIns="109728" tIns="36576" bIns="64008"/>
           <a:lstStyle/>
           <a:p>
-            <a:r>
-              <a:rPr sz="1100" b="1" i="0">
+            <a:pPr algn="ctr">
+              <a:spcAft>
+                <a:spcPts val="200"/>
+              </a:spcAft>
+            </a:pPr>
+            <a:r>
+              <a:rPr sz="1050" b="1" i="0">
+                <a:solidFill>
+                  <a:srgbClr val="17803D"/>
+                </a:solidFill>
+                <a:latin typeface="Trebuchet MS"/>
+              </a:rPr>
+              <a:t>IMPLEMENTED TODAY  ✓</a:t>
+            </a:r>
+          </a:p>
+          <a:p>
+            <a:r>
+              <a:rPr sz="919" b="0" i="0">
                 <a:solidFill>
                   <a:srgbClr val="1C2B3A"/>
                 </a:solidFill>
                 <a:latin typeface="Segoe UI"/>
               </a:rPr>
-              <a:t>Working prototype (this exact methodology, client-side):  </a:t>
-            </a:r>
-            <a:r>
-              <a:rPr sz="1100" b="0" i="1">
+              <a:t>3 metals · 6 scenarios · state-grid map · k-NN imputer · 1,000-run Monte Carlo · CBAM ₹ calculator · MCI chakra · benchmarks · Hindi UI · report — offline, zero backend</a:t>
+            </a:r>
+          </a:p>
+        </p:txBody>
+      </p:sp>
+      <p:sp>
+        <p:nvSpPr>
+          <p:cNvPr id="17430" name="Rounded Rectangle 17429"/>
+          <p:cNvSpPr/>
+          <p:nvPr/>
+        </p:nvSpPr>
+        <p:spPr>
+          <a:xfrm>
+            <a:off x="7882127" y="5248656"/>
+            <a:ext cx="3913632" cy="950976"/>
+          </a:xfrm>
+          <a:prstGeom prst="roundRect">
+            <a:avLst>
+              <a:gd name="adj" fmla="val 6000"/>
+            </a:avLst>
+          </a:prstGeom>
+          <a:solidFill>
+            <a:srgbClr val="EBF1F7"/>
+          </a:solidFill>
+          <a:ln w="12700">
+            <a:solidFill>
+              <a:srgbClr val="24466E"/>
+            </a:solidFill>
+          </a:ln>
+          <a:effectLst/>
+        </p:spPr>
+        <p:style>
+          <a:lnRef idx="1">
+            <a:schemeClr val="accent1"/>
+          </a:lnRef>
+          <a:fillRef idx="3">
+            <a:schemeClr val="accent1"/>
+          </a:fillRef>
+          <a:effectRef idx="2">
+            <a:schemeClr val="accent1"/>
+          </a:effectRef>
+          <a:fontRef idx="minor">
+            <a:schemeClr val="lt1"/>
+          </a:fontRef>
+        </p:style>
+        <p:txBody>
+          <a:bodyPr rtlCol="0" anchor="t" wrap="square" lIns="109728" rIns="109728" tIns="36576" bIns="64008"/>
+          <a:lstStyle/>
+          <a:p>
+            <a:pPr algn="ctr">
+              <a:spcAft>
+                <a:spcPts val="200"/>
+              </a:spcAft>
+            </a:pPr>
+            <a:r>
+              <a:rPr sz="1050" b="1" i="0">
+                <a:solidFill>
+                  <a:srgbClr val="24466E"/>
+                </a:solidFill>
+                <a:latin typeface="Trebuchet MS"/>
+              </a:rPr>
+              <a:t>FULL BUILD  (planned, spec ready)</a:t>
+            </a:r>
+          </a:p>
+          <a:p>
+            <a:r>
+              <a:rPr sz="919" b="0" i="0">
+                <a:solidFill>
+                  <a:srgbClr val="1C2B3A"/>
+                </a:solidFill>
+                <a:latin typeface="Segoe UI"/>
+              </a:rPr>
+              <a:t>Brightway2.5 matrix LCA · LightGBM imputer · LLM parser · FastAPI + PostgreSQL — full details: </a:t>
+            </a:r>
+            <a:r>
+              <a:rPr sz="919" b="0" i="0">
                 <a:solidFill>
                   <a:srgbClr val="B84E0A"/>
                 </a:solidFill>
                 <a:latin typeface="Segoe UI"/>
-              </a:rPr>
-              <a:t>demo video — &lt;add link&gt;   ·   </a:t>
-            </a:r>
-            <a:r>
-              <a:rPr sz="1100" b="0" i="0">
-                <a:solidFill>
-                  <a:srgbClr val="B84E0A"/>
-                </a:solidFill>
-                <a:latin typeface="Segoe UI"/>
                 <a:hlinkClick r:id="rId4"/>
               </a:rPr>
-              <a:t>technical documentation (PDF in repo)</a:t>
+              <a:t>technical PDF</a:t>
+            </a:r>
+            <a:r>
+              <a:rPr sz="919" b="0" i="1">
+                <a:solidFill>
+                  <a:srgbClr val="5A6B7B"/>
+                </a:solidFill>
+                <a:latin typeface="Segoe UI"/>
+              </a:rPr>
+              <a:t>  ·  demo video — &lt;add link&gt;</a:t>
             </a:r>
           </a:p>
         </p:txBody>
@@ -9292,11 +9528,11 @@
           <a:p>
             <a:pPr algn="ctr">
               <a:spcAft>
-                <a:spcPts val="600"/>
+                <a:spcPts val="400"/>
               </a:spcAft>
             </a:pPr>
             <a:r>
-              <a:rPr sz="1500" b="1" i="0">
+              <a:rPr sz="1300" b="1" i="0">
                 <a:solidFill>
                   <a:srgbClr val="24466E"/>
                 </a:solidFill>
@@ -9308,11 +9544,11 @@
           <a:p>
             <a:pPr>
               <a:spcAft>
-                <a:spcPts val="800"/>
+                <a:spcPts val="500"/>
               </a:spcAft>
             </a:pPr>
             <a:r>
-              <a:rPr sz="1150" b="1" i="0">
+              <a:rPr sz="1050" b="1" i="0">
                 <a:solidFill>
                   <a:srgbClr val="B84E0A"/>
                 </a:solidFill>
@@ -9321,7 +9557,7 @@
               <a:t>•  </a:t>
             </a:r>
             <a:r>
-              <a:rPr sz="1150" b="1" i="0">
+              <a:rPr sz="1050" b="1" i="0">
                 <a:solidFill>
                   <a:srgbClr val="1C2B3A"/>
                 </a:solidFill>
@@ -9330,23 +9566,23 @@
               <a:t>100% free data — </a:t>
             </a:r>
             <a:r>
-              <a:rPr sz="1150" b="0" i="0">
+              <a:rPr sz="1050" b="0" i="0">
                 <a:solidFill>
                   <a:srgbClr val="1C2B3A"/>
                 </a:solidFill>
                 <a:latin typeface="Segoe UI"/>
               </a:rPr>
-              <a:t>IAI, worldsteel, CEA, EF 3.1, IDEMAT, US LCI: no paid-licence blocker anywhere in the pipeline</a:t>
+              <a:t>IAI, worldsteel, CEA, EF 3.1, IDEMAT: no paid-licence blocker anywhere in the pipeline</a:t>
             </a:r>
           </a:p>
           <a:p>
             <a:pPr>
               <a:spcAft>
-                <a:spcPts val="800"/>
+                <a:spcPts val="500"/>
               </a:spcAft>
             </a:pPr>
             <a:r>
-              <a:rPr sz="1150" b="1" i="0">
+              <a:rPr sz="1050" b="1" i="0">
                 <a:solidFill>
                   <a:srgbClr val="B84E0A"/>
                 </a:solidFill>
@@ -9355,32 +9591,32 @@
               <a:t>•  </a:t>
             </a:r>
             <a:r>
-              <a:rPr sz="1150" b="1" i="0">
+              <a:rPr sz="1050" b="1" i="0">
                 <a:solidFill>
                   <a:srgbClr val="1C2B3A"/>
                 </a:solidFill>
                 <a:latin typeface="Segoe UI"/>
               </a:rPr>
-              <a:t>Already validated: </a:t>
-            </a:r>
-            <a:r>
-              <a:rPr sz="1150" b="0" i="0">
+              <a:t>Working prototype live — </a:t>
+            </a:r>
+            <a:r>
+              <a:rPr sz="1050" b="0" i="0">
                 <a:solidFill>
                   <a:srgbClr val="1C2B3A"/>
                 </a:solidFill>
                 <a:latin typeface="Segoe UI"/>
               </a:rPr>
-              <a:t>prototype outputs 16.6 / 0.92 / 2.19 / 0.70 t CO₂e/t (Al primary · Al recycled · BF-BOF · EAF) sit inside published ranges — IAI 16–20 &amp; 0.5–1.5, worldsteel 1.9–2.4 &amp; 0.4–1.0</a:t>
+              <a:t>3 metals, state-grid map, k-NN imputer, Monte Carlo, CBAM, Hindi UI; full-build plan written</a:t>
             </a:r>
           </a:p>
           <a:p>
             <a:pPr>
               <a:spcAft>
-                <a:spcPts val="800"/>
+                <a:spcPts val="500"/>
               </a:spcAft>
             </a:pPr>
             <a:r>
-              <a:rPr sz="1150" b="1" i="0">
+              <a:rPr sz="1050" b="1" i="0">
                 <a:solidFill>
                   <a:srgbClr val="B84E0A"/>
                 </a:solidFill>
@@ -9389,56 +9625,33 @@
               <a:t>•  </a:t>
             </a:r>
             <a:r>
-              <a:rPr sz="1150" b="1" i="0">
+              <a:rPr sz="1050" b="1" i="0">
                 <a:solidFill>
                   <a:srgbClr val="1C2B3A"/>
                 </a:solidFill>
                 <a:latin typeface="Segoe UI"/>
               </a:rPr>
-              <a:t>Working prototype live </a:t>
-            </a:r>
-            <a:r>
-              <a:rPr sz="1150" b="0" i="0">
+              <a:t>ML needs no scarce dataset — </a:t>
+            </a:r>
+            <a:r>
+              <a:rPr sz="1050" b="0" i="0">
                 <a:solidFill>
                   <a:srgbClr val="1C2B3A"/>
                 </a:solidFill>
                 <a:latin typeface="Segoe UI"/>
               </a:rPr>
-              <a:t>— 3 metals, state-grid map, k-NN imputer, Monte Carlo, CBAM calculator, Hindi UI; 4-week full-build plan written</a:t>
-            </a:r>
-          </a:p>
-          <a:p>
-            <a:pPr>
-              <a:spcAft>
-                <a:spcPts val="800"/>
-              </a:spcAft>
-            </a:pPr>
-            <a:r>
-              <a:rPr sz="1150" b="1" i="0">
-                <a:solidFill>
-                  <a:srgbClr val="B84E0A"/>
-                </a:solidFill>
-                <a:latin typeface="Segoe UI"/>
-              </a:rPr>
-              <a:t>•  </a:t>
-            </a:r>
-            <a:r>
-              <a:rPr sz="1150" b="1" i="0">
-                <a:solidFill>
-                  <a:srgbClr val="1C2B3A"/>
-                </a:solidFill>
-                <a:latin typeface="Segoe UI"/>
-              </a:rPr>
-              <a:t>ML needs no scarce dataset — </a:t>
-            </a:r>
-            <a:r>
-              <a:rPr sz="1150" b="0" i="0">
-                <a:solidFill>
-                  <a:srgbClr val="1C2B3A"/>
-                </a:solidFill>
-                <a:latin typeface="Segoe UI"/>
-              </a:rPr>
-              <a:t>imputer &amp; surrogate train on physics-generated scenarios from our own engine</a:t>
+              <a:t>the imputer trains on physics-generated scenarios from our own engine</a:t>
+            </a:r>
+          </a:p>
+          <a:p>
+            <a:r>
+              <a:rPr sz="1050" b="1" i="0">
+                <a:solidFill>
+                  <a:srgbClr val="24466E"/>
+                </a:solidFill>
+                <a:latin typeface="Segoe UI"/>
+              </a:rPr>
+              <a:t>Validated against published values (t CO₂e / t metal):</a:t>
             </a:r>
           </a:p>
         </p:txBody>
@@ -9446,6 +9659,441 @@
       <p:graphicFrame>
         <p:nvGraphicFramePr>
           <p:cNvPr id="17412" name="Table 17411"/>
+          <p:cNvGraphicFramePr>
+            <a:graphicFrameLocks noGrp="1"/>
+          </p:cNvGraphicFramePr>
+          <p:nvPr/>
+        </p:nvGraphicFramePr>
+        <p:xfrm>
+          <a:off x="530352" y="3675887"/>
+          <a:ext cx="4261103" cy="2331720"/>
+        </p:xfrm>
+        <a:graphic>
+          <a:graphicData uri="http://schemas.openxmlformats.org/drawingml/2006/table">
+            <a:tbl>
+              <a:tblPr firstRow="1" bandRow="1">
+                <a:tableStyleId>{5C22544A-7EE6-4342-B048-85BDC9FD1C3A}</a:tableStyleId>
+              </a:tblPr>
+              <a:tblGrid>
+                <a:gridCol w="2084831"/>
+                <a:gridCol w="658368"/>
+                <a:gridCol w="1517904"/>
+              </a:tblGrid>
+              <a:tr h="388620">
+                <a:tc>
+                  <a:txBody>
+                    <a:bodyPr wrap="square"/>
+                    <a:lstStyle/>
+                    <a:p>
+                      <a:r>
+                        <a:rPr sz="950" b="1" i="0">
+                          <a:solidFill>
+                            <a:srgbClr val="FFFFFF"/>
+                          </a:solidFill>
+                          <a:latin typeface="Trebuchet MS"/>
+                        </a:rPr>
+                        <a:t>Route</a:t>
+                      </a:r>
+                    </a:p>
+                  </a:txBody>
+                  <a:tcPr marL="54864" marR="36576" marT="18288" marB="18288" anchor="ctr">
+                    <a:solidFill>
+                      <a:srgbClr val="24466E"/>
+                    </a:solidFill>
+                  </a:tcPr>
+                </a:tc>
+                <a:tc>
+                  <a:txBody>
+                    <a:bodyPr wrap="square"/>
+                    <a:lstStyle/>
+                    <a:p>
+                      <a:r>
+                        <a:rPr sz="950" b="1" i="0">
+                          <a:solidFill>
+                            <a:srgbClr val="FFFFFF"/>
+                          </a:solidFill>
+                          <a:latin typeface="Trebuchet MS"/>
+                        </a:rPr>
+                        <a:t>Ours</a:t>
+                      </a:r>
+                    </a:p>
+                  </a:txBody>
+                  <a:tcPr marL="54864" marR="36576" marT="18288" marB="18288" anchor="ctr">
+                    <a:solidFill>
+                      <a:srgbClr val="24466E"/>
+                    </a:solidFill>
+                  </a:tcPr>
+                </a:tc>
+                <a:tc>
+                  <a:txBody>
+                    <a:bodyPr wrap="square"/>
+                    <a:lstStyle/>
+                    <a:p>
+                      <a:r>
+                        <a:rPr sz="950" b="1" i="0">
+                          <a:solidFill>
+                            <a:srgbClr val="FFFFFF"/>
+                          </a:solidFill>
+                          <a:latin typeface="Trebuchet MS"/>
+                        </a:rPr>
+                        <a:t>Published range</a:t>
+                      </a:r>
+                    </a:p>
+                  </a:txBody>
+                  <a:tcPr marL="54864" marR="36576" marT="18288" marB="18288" anchor="ctr">
+                    <a:solidFill>
+                      <a:srgbClr val="24466E"/>
+                    </a:solidFill>
+                  </a:tcPr>
+                </a:tc>
+              </a:tr>
+              <a:tr h="388620">
+                <a:tc>
+                  <a:txBody>
+                    <a:bodyPr wrap="square"/>
+                    <a:lstStyle/>
+                    <a:p>
+                      <a:r>
+                        <a:rPr sz="950" b="0" i="0">
+                          <a:solidFill>
+                            <a:srgbClr val="1C2B3A"/>
+                          </a:solidFill>
+                          <a:latin typeface="Segoe UI"/>
+                        </a:rPr>
+                        <a:t>Aluminium — primary (IN grid)</a:t>
+                      </a:r>
+                    </a:p>
+                  </a:txBody>
+                  <a:tcPr marL="54864" marR="36576" marT="18288" marB="18288" anchor="ctr">
+                    <a:solidFill>
+                      <a:srgbClr val="FFFFFF"/>
+                    </a:solidFill>
+                  </a:tcPr>
+                </a:tc>
+                <a:tc>
+                  <a:txBody>
+                    <a:bodyPr wrap="square"/>
+                    <a:lstStyle/>
+                    <a:p>
+                      <a:r>
+                        <a:rPr sz="950" b="1" i="0">
+                          <a:solidFill>
+                            <a:srgbClr val="17803D"/>
+                          </a:solidFill>
+                          <a:latin typeface="Segoe UI"/>
+                        </a:rPr>
+                        <a:t>16.6</a:t>
+                      </a:r>
+                    </a:p>
+                  </a:txBody>
+                  <a:tcPr marL="54864" marR="36576" marT="18288" marB="18288" anchor="ctr">
+                    <a:solidFill>
+                      <a:srgbClr val="FFFFFF"/>
+                    </a:solidFill>
+                  </a:tcPr>
+                </a:tc>
+                <a:tc>
+                  <a:txBody>
+                    <a:bodyPr wrap="square"/>
+                    <a:lstStyle/>
+                    <a:p>
+                      <a:r>
+                        <a:rPr sz="950" b="0" i="0">
+                          <a:solidFill>
+                            <a:srgbClr val="5A6B7B"/>
+                          </a:solidFill>
+                          <a:latin typeface="Segoe UI"/>
+                        </a:rPr>
+                        <a:t>16–20 (IAI)</a:t>
+                      </a:r>
+                    </a:p>
+                  </a:txBody>
+                  <a:tcPr marL="54864" marR="36576" marT="18288" marB="18288" anchor="ctr">
+                    <a:solidFill>
+                      <a:srgbClr val="FFFFFF"/>
+                    </a:solidFill>
+                  </a:tcPr>
+                </a:tc>
+              </a:tr>
+              <a:tr h="388620">
+                <a:tc>
+                  <a:txBody>
+                    <a:bodyPr wrap="square"/>
+                    <a:lstStyle/>
+                    <a:p>
+                      <a:r>
+                        <a:rPr sz="950" b="0" i="0">
+                          <a:solidFill>
+                            <a:srgbClr val="1C2B3A"/>
+                          </a:solidFill>
+                          <a:latin typeface="Segoe UI"/>
+                        </a:rPr>
+                        <a:t>Aluminium — recycled</a:t>
+                      </a:r>
+                    </a:p>
+                  </a:txBody>
+                  <a:tcPr marL="54864" marR="36576" marT="18288" marB="18288" anchor="ctr">
+                    <a:solidFill>
+                      <a:srgbClr val="FFFFFF"/>
+                    </a:solidFill>
+                  </a:tcPr>
+                </a:tc>
+                <a:tc>
+                  <a:txBody>
+                    <a:bodyPr wrap="square"/>
+                    <a:lstStyle/>
+                    <a:p>
+                      <a:r>
+                        <a:rPr sz="950" b="1" i="0">
+                          <a:solidFill>
+                            <a:srgbClr val="17803D"/>
+                          </a:solidFill>
+                          <a:latin typeface="Segoe UI"/>
+                        </a:rPr>
+                        <a:t>0.92</a:t>
+                      </a:r>
+                    </a:p>
+                  </a:txBody>
+                  <a:tcPr marL="54864" marR="36576" marT="18288" marB="18288" anchor="ctr">
+                    <a:solidFill>
+                      <a:srgbClr val="FFFFFF"/>
+                    </a:solidFill>
+                  </a:tcPr>
+                </a:tc>
+                <a:tc>
+                  <a:txBody>
+                    <a:bodyPr wrap="square"/>
+                    <a:lstStyle/>
+                    <a:p>
+                      <a:r>
+                        <a:rPr sz="950" b="0" i="0">
+                          <a:solidFill>
+                            <a:srgbClr val="5A6B7B"/>
+                          </a:solidFill>
+                          <a:latin typeface="Segoe UI"/>
+                        </a:rPr>
+                        <a:t>0.5–1.5 (IAI)</a:t>
+                      </a:r>
+                    </a:p>
+                  </a:txBody>
+                  <a:tcPr marL="54864" marR="36576" marT="18288" marB="18288" anchor="ctr">
+                    <a:solidFill>
+                      <a:srgbClr val="FFFFFF"/>
+                    </a:solidFill>
+                  </a:tcPr>
+                </a:tc>
+              </a:tr>
+              <a:tr h="388620">
+                <a:tc>
+                  <a:txBody>
+                    <a:bodyPr wrap="square"/>
+                    <a:lstStyle/>
+                    <a:p>
+                      <a:r>
+                        <a:rPr sz="950" b="0" i="0">
+                          <a:solidFill>
+                            <a:srgbClr val="1C2B3A"/>
+                          </a:solidFill>
+                          <a:latin typeface="Segoe UI"/>
+                        </a:rPr>
+                        <a:t>Steel — BF-BOF</a:t>
+                      </a:r>
+                    </a:p>
+                  </a:txBody>
+                  <a:tcPr marL="54864" marR="36576" marT="18288" marB="18288" anchor="ctr">
+                    <a:solidFill>
+                      <a:srgbClr val="FFFFFF"/>
+                    </a:solidFill>
+                  </a:tcPr>
+                </a:tc>
+                <a:tc>
+                  <a:txBody>
+                    <a:bodyPr wrap="square"/>
+                    <a:lstStyle/>
+                    <a:p>
+                      <a:r>
+                        <a:rPr sz="950" b="1" i="0">
+                          <a:solidFill>
+                            <a:srgbClr val="17803D"/>
+                          </a:solidFill>
+                          <a:latin typeface="Segoe UI"/>
+                        </a:rPr>
+                        <a:t>2.19</a:t>
+                      </a:r>
+                    </a:p>
+                  </a:txBody>
+                  <a:tcPr marL="54864" marR="36576" marT="18288" marB="18288" anchor="ctr">
+                    <a:solidFill>
+                      <a:srgbClr val="FFFFFF"/>
+                    </a:solidFill>
+                  </a:tcPr>
+                </a:tc>
+                <a:tc>
+                  <a:txBody>
+                    <a:bodyPr wrap="square"/>
+                    <a:lstStyle/>
+                    <a:p>
+                      <a:r>
+                        <a:rPr sz="950" b="0" i="0">
+                          <a:solidFill>
+                            <a:srgbClr val="5A6B7B"/>
+                          </a:solidFill>
+                          <a:latin typeface="Segoe UI"/>
+                        </a:rPr>
+                        <a:t>1.9–2.4 (worldsteel)</a:t>
+                      </a:r>
+                    </a:p>
+                  </a:txBody>
+                  <a:tcPr marL="54864" marR="36576" marT="18288" marB="18288" anchor="ctr">
+                    <a:solidFill>
+                      <a:srgbClr val="FFFFFF"/>
+                    </a:solidFill>
+                  </a:tcPr>
+                </a:tc>
+              </a:tr>
+              <a:tr h="388620">
+                <a:tc>
+                  <a:txBody>
+                    <a:bodyPr wrap="square"/>
+                    <a:lstStyle/>
+                    <a:p>
+                      <a:r>
+                        <a:rPr sz="950" b="0" i="0">
+                          <a:solidFill>
+                            <a:srgbClr val="1C2B3A"/>
+                          </a:solidFill>
+                          <a:latin typeface="Segoe UI"/>
+                        </a:rPr>
+                        <a:t>Steel — EAF (scrap)</a:t>
+                      </a:r>
+                    </a:p>
+                  </a:txBody>
+                  <a:tcPr marL="54864" marR="36576" marT="18288" marB="18288" anchor="ctr">
+                    <a:solidFill>
+                      <a:srgbClr val="FFFFFF"/>
+                    </a:solidFill>
+                  </a:tcPr>
+                </a:tc>
+                <a:tc>
+                  <a:txBody>
+                    <a:bodyPr wrap="square"/>
+                    <a:lstStyle/>
+                    <a:p>
+                      <a:r>
+                        <a:rPr sz="950" b="1" i="0">
+                          <a:solidFill>
+                            <a:srgbClr val="17803D"/>
+                          </a:solidFill>
+                          <a:latin typeface="Segoe UI"/>
+                        </a:rPr>
+                        <a:t>0.70</a:t>
+                      </a:r>
+                    </a:p>
+                  </a:txBody>
+                  <a:tcPr marL="54864" marR="36576" marT="18288" marB="18288" anchor="ctr">
+                    <a:solidFill>
+                      <a:srgbClr val="FFFFFF"/>
+                    </a:solidFill>
+                  </a:tcPr>
+                </a:tc>
+                <a:tc>
+                  <a:txBody>
+                    <a:bodyPr wrap="square"/>
+                    <a:lstStyle/>
+                    <a:p>
+                      <a:r>
+                        <a:rPr sz="950" b="0" i="0">
+                          <a:solidFill>
+                            <a:srgbClr val="5A6B7B"/>
+                          </a:solidFill>
+                          <a:latin typeface="Segoe UI"/>
+                        </a:rPr>
+                        <a:t>0.4–1.0 (worldsteel)</a:t>
+                      </a:r>
+                    </a:p>
+                  </a:txBody>
+                  <a:tcPr marL="54864" marR="36576" marT="18288" marB="18288" anchor="ctr">
+                    <a:solidFill>
+                      <a:srgbClr val="FFFFFF"/>
+                    </a:solidFill>
+                  </a:tcPr>
+                </a:tc>
+              </a:tr>
+              <a:tr h="388620">
+                <a:tc>
+                  <a:txBody>
+                    <a:bodyPr wrap="square"/>
+                    <a:lstStyle/>
+                    <a:p>
+                      <a:r>
+                        <a:rPr sz="950" b="0" i="0">
+                          <a:solidFill>
+                            <a:srgbClr val="1C2B3A"/>
+                          </a:solidFill>
+                          <a:latin typeface="Segoe UI"/>
+                        </a:rPr>
+                        <a:t>Copper — primary</a:t>
+                      </a:r>
+                    </a:p>
+                  </a:txBody>
+                  <a:tcPr marL="54864" marR="36576" marT="18288" marB="18288" anchor="ctr">
+                    <a:solidFill>
+                      <a:srgbClr val="FFFFFF"/>
+                    </a:solidFill>
+                  </a:tcPr>
+                </a:tc>
+                <a:tc>
+                  <a:txBody>
+                    <a:bodyPr wrap="square"/>
+                    <a:lstStyle/>
+                    <a:p>
+                      <a:r>
+                        <a:rPr sz="950" b="1" i="0">
+                          <a:solidFill>
+                            <a:srgbClr val="17803D"/>
+                          </a:solidFill>
+                          <a:latin typeface="Segoe UI"/>
+                        </a:rPr>
+                        <a:t>4.24</a:t>
+                      </a:r>
+                    </a:p>
+                  </a:txBody>
+                  <a:tcPr marL="54864" marR="36576" marT="18288" marB="18288" anchor="ctr">
+                    <a:solidFill>
+                      <a:srgbClr val="FFFFFF"/>
+                    </a:solidFill>
+                  </a:tcPr>
+                </a:tc>
+                <a:tc>
+                  <a:txBody>
+                    <a:bodyPr wrap="square"/>
+                    <a:lstStyle/>
+                    <a:p>
+                      <a:r>
+                        <a:rPr sz="950" b="0" i="0">
+                          <a:solidFill>
+                            <a:srgbClr val="5A6B7B"/>
+                          </a:solidFill>
+                          <a:latin typeface="Segoe UI"/>
+                        </a:rPr>
+                        <a:t>≈4.2 (EF 3.1, indic.)</a:t>
+                      </a:r>
+                    </a:p>
+                  </a:txBody>
+                  <a:tcPr marL="54864" marR="36576" marT="18288" marB="18288" anchor="ctr">
+                    <a:solidFill>
+                      <a:srgbClr val="FFFFFF"/>
+                    </a:solidFill>
+                  </a:tcPr>
+                </a:tc>
+              </a:tr>
+            </a:tbl>
+          </a:graphicData>
+        </a:graphic>
+      </p:graphicFrame>
+      <p:graphicFrame>
+        <p:nvGraphicFramePr>
+          <p:cNvPr id="17413" name="Table 17412"/>
           <p:cNvGraphicFramePr>
             <a:graphicFrameLocks noGrp="1"/>
           </p:cNvGraphicFramePr>
@@ -9730,7 +10378,7 @@
                           </a:solidFill>
                           <a:latin typeface="Segoe UI"/>
                         </a:rPr>
-                        <a:t>v1 locked: Al + steel, 4 impact categories; copper &amp; Brightway as stretch</a:t>
+                        <a:t>v1 scope locked and SHIPPED: 3 metals, 4 impact categories; Brightway2.5 swap reserved for full build</a:t>
                       </a:r>
                     </a:p>
                   </a:txBody>

</xml_diff>